<commit_message>
Simplify Lecture 2 demo 3: remove RAG bonus, semantic vs keyword only
Co-authored-by: Cursor <cursoragent@cursor.com>
</commit_message>
<xml_diff>
--- a/lecture2/L2_Embeddings_VectorDatabases_DevOps.pptx
+++ b/lecture2/L2_Embeddings_VectorDatabases_DevOps.pptx
@@ -5,31 +5,31 @@
     <p:sldMasterId id="2147483648" r:id="rId1"/>
   </p:sldMasterIdLst>
   <p:sldIdLst>
-    <p:sldId id="256" r:id="rId7"/>
-    <p:sldId id="257" r:id="rId8"/>
-    <p:sldId id="258" r:id="rId9"/>
-    <p:sldId id="259" r:id="rId10"/>
-    <p:sldId id="260" r:id="rId11"/>
-    <p:sldId id="261" r:id="rId12"/>
-    <p:sldId id="262" r:id="rId13"/>
-    <p:sldId id="263" r:id="rId14"/>
-    <p:sldId id="264" r:id="rId15"/>
-    <p:sldId id="265" r:id="rId16"/>
-    <p:sldId id="266" r:id="rId17"/>
-    <p:sldId id="267" r:id="rId18"/>
-    <p:sldId id="268" r:id="rId19"/>
-    <p:sldId id="269" r:id="rId20"/>
-    <p:sldId id="270" r:id="rId21"/>
-    <p:sldId id="271" r:id="rId22"/>
-    <p:sldId id="272" r:id="rId23"/>
-    <p:sldId id="273" r:id="rId24"/>
-    <p:sldId id="274" r:id="rId25"/>
-    <p:sldId id="275" r:id="rId26"/>
-    <p:sldId id="276" r:id="rId27"/>
-    <p:sldId id="277" r:id="rId28"/>
-    <p:sldId id="278" r:id="rId29"/>
+    <p:sldId id="256" r:id="rId2"/>
+    <p:sldId id="257" r:id="rId3"/>
+    <p:sldId id="258" r:id="rId4"/>
+    <p:sldId id="259" r:id="rId5"/>
+    <p:sldId id="260" r:id="rId6"/>
+    <p:sldId id="261" r:id="rId7"/>
+    <p:sldId id="262" r:id="rId8"/>
+    <p:sldId id="263" r:id="rId9"/>
+    <p:sldId id="264" r:id="rId10"/>
+    <p:sldId id="265" r:id="rId11"/>
+    <p:sldId id="266" r:id="rId12"/>
+    <p:sldId id="267" r:id="rId13"/>
+    <p:sldId id="268" r:id="rId14"/>
+    <p:sldId id="269" r:id="rId15"/>
+    <p:sldId id="270" r:id="rId16"/>
+    <p:sldId id="271" r:id="rId17"/>
+    <p:sldId id="272" r:id="rId18"/>
+    <p:sldId id="273" r:id="rId19"/>
+    <p:sldId id="274" r:id="rId20"/>
+    <p:sldId id="275" r:id="rId21"/>
+    <p:sldId id="276" r:id="rId22"/>
+    <p:sldId id="277" r:id="rId23"/>
+    <p:sldId id="278" r:id="rId24"/>
   </p:sldIdLst>
-  <p:sldSz cx="12191695" cy="6858000" type="screen4x3"/>
+  <p:sldSz cx="12192000" cy="6858000"/>
   <p:notesSz cx="6858000" cy="9144000"/>
   <p:defaultTextStyle>
     <a:defPPr>
@@ -126,6 +126,22 @@
       </a:defRPr>
     </a:lvl9pPr>
   </p:defaultTextStyle>
+  <p:extLst>
+    <p:ext uri="{EFAFB233-063F-42B5-8137-9DF3F51BA10A}">
+      <p15:sldGuideLst xmlns:p15="http://schemas.microsoft.com/office/powerpoint/2012/main">
+        <p15:guide id="1" orient="horz" pos="2160">
+          <p15:clr>
+            <a:srgbClr val="A4A3A4"/>
+          </p15:clr>
+        </p15:guide>
+        <p15:guide id="2" pos="2880">
+          <p15:clr>
+            <a:srgbClr val="A4A3A4"/>
+          </p15:clr>
+        </p15:guide>
+      </p15:sldGuideLst>
+    </p:ext>
+  </p:extLst>
 </p:presentation>
 </file>
 
@@ -167,10 +183,9 @@
           <a:lstStyle/>
           <a:p>
             <a:r>
-              <a:rPr lang="en-US" smtClean="0"/>
+              <a:rPr lang="en-US"/>
               <a:t>Click to edit Master title style</a:t>
             </a:r>
-            <a:endParaRPr lang="en-US"/>
           </a:p>
         </p:txBody>
       </p:sp>
@@ -286,10 +301,9 @@
           </a:lstStyle>
           <a:p>
             <a:r>
-              <a:rPr lang="en-US" smtClean="0"/>
+              <a:rPr lang="en-US"/>
               <a:t>Click to edit Master subtitle style</a:t>
             </a:r>
-            <a:endParaRPr lang="en-US"/>
           </a:p>
         </p:txBody>
       </p:sp>
@@ -310,7 +324,7 @@
           <a:p>
             <a:fld id="{5BCAD085-E8A6-8845-BD4E-CB4CCA059FC4}" type="datetimeFigureOut">
               <a:rPr lang="en-US" smtClean="0"/>
-              <a:t>1/27/13</a:t>
+              <a:t>8/7/2026</a:t>
             </a:fld>
             <a:endParaRPr lang="en-US"/>
           </a:p>
@@ -404,10 +418,9 @@
           <a:lstStyle/>
           <a:p>
             <a:r>
-              <a:rPr lang="en-US" smtClean="0"/>
+              <a:rPr lang="en-US"/>
               <a:t>Click to edit Master title style</a:t>
             </a:r>
-            <a:endParaRPr lang="en-US"/>
           </a:p>
         </p:txBody>
       </p:sp>
@@ -428,38 +441,37 @@
           <a:p>
             <a:pPr lvl="0"/>
             <a:r>
-              <a:rPr lang="en-US" smtClean="0"/>
+              <a:rPr lang="en-US"/>
               <a:t>Click to edit Master text styles</a:t>
             </a:r>
           </a:p>
           <a:p>
             <a:pPr lvl="1"/>
             <a:r>
-              <a:rPr lang="en-US" smtClean="0"/>
+              <a:rPr lang="en-US"/>
               <a:t>Second level</a:t>
             </a:r>
           </a:p>
           <a:p>
             <a:pPr lvl="2"/>
             <a:r>
-              <a:rPr lang="en-US" smtClean="0"/>
+              <a:rPr lang="en-US"/>
               <a:t>Third level</a:t>
             </a:r>
           </a:p>
           <a:p>
             <a:pPr lvl="3"/>
             <a:r>
-              <a:rPr lang="en-US" smtClean="0"/>
+              <a:rPr lang="en-US"/>
               <a:t>Fourth level</a:t>
             </a:r>
           </a:p>
           <a:p>
             <a:pPr lvl="4"/>
             <a:r>
-              <a:rPr lang="en-US" smtClean="0"/>
+              <a:rPr lang="en-US"/>
               <a:t>Fifth level</a:t>
             </a:r>
-            <a:endParaRPr lang="en-US"/>
           </a:p>
         </p:txBody>
       </p:sp>
@@ -480,7 +492,7 @@
           <a:p>
             <a:fld id="{5BCAD085-E8A6-8845-BD4E-CB4CCA059FC4}" type="datetimeFigureOut">
               <a:rPr lang="en-US" smtClean="0"/>
-              <a:t>1/27/13</a:t>
+              <a:t>8/7/2026</a:t>
             </a:fld>
             <a:endParaRPr lang="en-US"/>
           </a:p>
@@ -579,10 +591,9 @@
           <a:lstStyle/>
           <a:p>
             <a:r>
-              <a:rPr lang="en-US" smtClean="0"/>
+              <a:rPr lang="en-US"/>
               <a:t>Click to edit Master title style</a:t>
             </a:r>
-            <a:endParaRPr lang="en-US"/>
           </a:p>
         </p:txBody>
       </p:sp>
@@ -608,38 +619,37 @@
           <a:p>
             <a:pPr lvl="0"/>
             <a:r>
-              <a:rPr lang="en-US" smtClean="0"/>
+              <a:rPr lang="en-US"/>
               <a:t>Click to edit Master text styles</a:t>
             </a:r>
           </a:p>
           <a:p>
             <a:pPr lvl="1"/>
             <a:r>
-              <a:rPr lang="en-US" smtClean="0"/>
+              <a:rPr lang="en-US"/>
               <a:t>Second level</a:t>
             </a:r>
           </a:p>
           <a:p>
             <a:pPr lvl="2"/>
             <a:r>
-              <a:rPr lang="en-US" smtClean="0"/>
+              <a:rPr lang="en-US"/>
               <a:t>Third level</a:t>
             </a:r>
           </a:p>
           <a:p>
             <a:pPr lvl="3"/>
             <a:r>
-              <a:rPr lang="en-US" smtClean="0"/>
+              <a:rPr lang="en-US"/>
               <a:t>Fourth level</a:t>
             </a:r>
           </a:p>
           <a:p>
             <a:pPr lvl="4"/>
             <a:r>
-              <a:rPr lang="en-US" smtClean="0"/>
+              <a:rPr lang="en-US"/>
               <a:t>Fifth level</a:t>
             </a:r>
-            <a:endParaRPr lang="en-US"/>
           </a:p>
         </p:txBody>
       </p:sp>
@@ -660,7 +670,7 @@
           <a:p>
             <a:fld id="{5BCAD085-E8A6-8845-BD4E-CB4CCA059FC4}" type="datetimeFigureOut">
               <a:rPr lang="en-US" smtClean="0"/>
-              <a:t>1/27/13</a:t>
+              <a:t>8/7/2026</a:t>
             </a:fld>
             <a:endParaRPr lang="en-US"/>
           </a:p>
@@ -754,10 +764,9 @@
           <a:lstStyle/>
           <a:p>
             <a:r>
-              <a:rPr lang="en-US" smtClean="0"/>
+              <a:rPr lang="en-US"/>
               <a:t>Click to edit Master title style</a:t>
             </a:r>
-            <a:endParaRPr lang="en-US"/>
           </a:p>
         </p:txBody>
       </p:sp>
@@ -778,38 +787,37 @@
           <a:p>
             <a:pPr lvl="0"/>
             <a:r>
-              <a:rPr lang="en-US" smtClean="0"/>
+              <a:rPr lang="en-US"/>
               <a:t>Click to edit Master text styles</a:t>
             </a:r>
           </a:p>
           <a:p>
             <a:pPr lvl="1"/>
             <a:r>
-              <a:rPr lang="en-US" smtClean="0"/>
+              <a:rPr lang="en-US"/>
               <a:t>Second level</a:t>
             </a:r>
           </a:p>
           <a:p>
             <a:pPr lvl="2"/>
             <a:r>
-              <a:rPr lang="en-US" smtClean="0"/>
+              <a:rPr lang="en-US"/>
               <a:t>Third level</a:t>
             </a:r>
           </a:p>
           <a:p>
             <a:pPr lvl="3"/>
             <a:r>
-              <a:rPr lang="en-US" smtClean="0"/>
+              <a:rPr lang="en-US"/>
               <a:t>Fourth level</a:t>
             </a:r>
           </a:p>
           <a:p>
             <a:pPr lvl="4"/>
             <a:r>
-              <a:rPr lang="en-US" smtClean="0"/>
+              <a:rPr lang="en-US"/>
               <a:t>Fifth level</a:t>
             </a:r>
-            <a:endParaRPr lang="en-US"/>
           </a:p>
         </p:txBody>
       </p:sp>
@@ -830,7 +838,7 @@
           <a:p>
             <a:fld id="{5BCAD085-E8A6-8845-BD4E-CB4CCA059FC4}" type="datetimeFigureOut">
               <a:rPr lang="en-US" smtClean="0"/>
-              <a:t>1/27/13</a:t>
+              <a:t>8/7/2026</a:t>
             </a:fld>
             <a:endParaRPr lang="en-US"/>
           </a:p>
@@ -933,10 +941,9 @@
           </a:lstStyle>
           <a:p>
             <a:r>
-              <a:rPr lang="en-US" smtClean="0"/>
+              <a:rPr lang="en-US"/>
               <a:t>Click to edit Master title style</a:t>
             </a:r>
-            <a:endParaRPr lang="en-US"/>
           </a:p>
         </p:txBody>
       </p:sp>
@@ -1053,7 +1060,7 @@
           <a:p>
             <a:pPr lvl="0"/>
             <a:r>
-              <a:rPr lang="en-US" smtClean="0"/>
+              <a:rPr lang="en-US"/>
               <a:t>Click to edit Master text styles</a:t>
             </a:r>
           </a:p>
@@ -1076,7 +1083,7 @@
           <a:p>
             <a:fld id="{5BCAD085-E8A6-8845-BD4E-CB4CCA059FC4}" type="datetimeFigureOut">
               <a:rPr lang="en-US" smtClean="0"/>
-              <a:t>1/27/13</a:t>
+              <a:t>8/7/2026</a:t>
             </a:fld>
             <a:endParaRPr lang="en-US"/>
           </a:p>
@@ -1170,10 +1177,9 @@
           <a:lstStyle/>
           <a:p>
             <a:r>
-              <a:rPr lang="en-US" smtClean="0"/>
+              <a:rPr lang="en-US"/>
               <a:t>Click to edit Master title style</a:t>
             </a:r>
-            <a:endParaRPr lang="en-US"/>
           </a:p>
         </p:txBody>
       </p:sp>
@@ -1227,38 +1233,37 @@
           <a:p>
             <a:pPr lvl="0"/>
             <a:r>
-              <a:rPr lang="en-US" smtClean="0"/>
+              <a:rPr lang="en-US"/>
               <a:t>Click to edit Master text styles</a:t>
             </a:r>
           </a:p>
           <a:p>
             <a:pPr lvl="1"/>
             <a:r>
-              <a:rPr lang="en-US" smtClean="0"/>
+              <a:rPr lang="en-US"/>
               <a:t>Second level</a:t>
             </a:r>
           </a:p>
           <a:p>
             <a:pPr lvl="2"/>
             <a:r>
-              <a:rPr lang="en-US" smtClean="0"/>
+              <a:rPr lang="en-US"/>
               <a:t>Third level</a:t>
             </a:r>
           </a:p>
           <a:p>
             <a:pPr lvl="3"/>
             <a:r>
-              <a:rPr lang="en-US" smtClean="0"/>
+              <a:rPr lang="en-US"/>
               <a:t>Fourth level</a:t>
             </a:r>
           </a:p>
           <a:p>
             <a:pPr lvl="4"/>
             <a:r>
-              <a:rPr lang="en-US" smtClean="0"/>
+              <a:rPr lang="en-US"/>
               <a:t>Fifth level</a:t>
             </a:r>
-            <a:endParaRPr lang="en-US"/>
           </a:p>
         </p:txBody>
       </p:sp>
@@ -1312,38 +1317,37 @@
           <a:p>
             <a:pPr lvl="0"/>
             <a:r>
-              <a:rPr lang="en-US" smtClean="0"/>
+              <a:rPr lang="en-US"/>
               <a:t>Click to edit Master text styles</a:t>
             </a:r>
           </a:p>
           <a:p>
             <a:pPr lvl="1"/>
             <a:r>
-              <a:rPr lang="en-US" smtClean="0"/>
+              <a:rPr lang="en-US"/>
               <a:t>Second level</a:t>
             </a:r>
           </a:p>
           <a:p>
             <a:pPr lvl="2"/>
             <a:r>
-              <a:rPr lang="en-US" smtClean="0"/>
+              <a:rPr lang="en-US"/>
               <a:t>Third level</a:t>
             </a:r>
           </a:p>
           <a:p>
             <a:pPr lvl="3"/>
             <a:r>
-              <a:rPr lang="en-US" smtClean="0"/>
+              <a:rPr lang="en-US"/>
               <a:t>Fourth level</a:t>
             </a:r>
           </a:p>
           <a:p>
             <a:pPr lvl="4"/>
             <a:r>
-              <a:rPr lang="en-US" smtClean="0"/>
+              <a:rPr lang="en-US"/>
               <a:t>Fifth level</a:t>
             </a:r>
-            <a:endParaRPr lang="en-US"/>
           </a:p>
         </p:txBody>
       </p:sp>
@@ -1364,7 +1368,7 @@
           <a:p>
             <a:fld id="{5BCAD085-E8A6-8845-BD4E-CB4CCA059FC4}" type="datetimeFigureOut">
               <a:rPr lang="en-US" smtClean="0"/>
-              <a:t>1/27/13</a:t>
+              <a:t>8/7/2026</a:t>
             </a:fld>
             <a:endParaRPr lang="en-US"/>
           </a:p>
@@ -1462,10 +1466,9 @@
           </a:lstStyle>
           <a:p>
             <a:r>
-              <a:rPr lang="en-US" smtClean="0"/>
+              <a:rPr lang="en-US"/>
               <a:t>Click to edit Master title style</a:t>
             </a:r>
-            <a:endParaRPr lang="en-US"/>
           </a:p>
         </p:txBody>
       </p:sp>
@@ -1528,7 +1531,7 @@
           <a:p>
             <a:pPr lvl="0"/>
             <a:r>
-              <a:rPr lang="en-US" smtClean="0"/>
+              <a:rPr lang="en-US"/>
               <a:t>Click to edit Master text styles</a:t>
             </a:r>
           </a:p>
@@ -1584,38 +1587,37 @@
           <a:p>
             <a:pPr lvl="0"/>
             <a:r>
-              <a:rPr lang="en-US" smtClean="0"/>
+              <a:rPr lang="en-US"/>
               <a:t>Click to edit Master text styles</a:t>
             </a:r>
           </a:p>
           <a:p>
             <a:pPr lvl="1"/>
             <a:r>
-              <a:rPr lang="en-US" smtClean="0"/>
+              <a:rPr lang="en-US"/>
               <a:t>Second level</a:t>
             </a:r>
           </a:p>
           <a:p>
             <a:pPr lvl="2"/>
             <a:r>
-              <a:rPr lang="en-US" smtClean="0"/>
+              <a:rPr lang="en-US"/>
               <a:t>Third level</a:t>
             </a:r>
           </a:p>
           <a:p>
             <a:pPr lvl="3"/>
             <a:r>
-              <a:rPr lang="en-US" smtClean="0"/>
+              <a:rPr lang="en-US"/>
               <a:t>Fourth level</a:t>
             </a:r>
           </a:p>
           <a:p>
             <a:pPr lvl="4"/>
             <a:r>
-              <a:rPr lang="en-US" smtClean="0"/>
+              <a:rPr lang="en-US"/>
               <a:t>Fifth level</a:t>
             </a:r>
-            <a:endParaRPr lang="en-US"/>
           </a:p>
         </p:txBody>
       </p:sp>
@@ -1678,7 +1680,7 @@
           <a:p>
             <a:pPr lvl="0"/>
             <a:r>
-              <a:rPr lang="en-US" smtClean="0"/>
+              <a:rPr lang="en-US"/>
               <a:t>Click to edit Master text styles</a:t>
             </a:r>
           </a:p>
@@ -1734,38 +1736,37 @@
           <a:p>
             <a:pPr lvl="0"/>
             <a:r>
-              <a:rPr lang="en-US" smtClean="0"/>
+              <a:rPr lang="en-US"/>
               <a:t>Click to edit Master text styles</a:t>
             </a:r>
           </a:p>
           <a:p>
             <a:pPr lvl="1"/>
             <a:r>
-              <a:rPr lang="en-US" smtClean="0"/>
+              <a:rPr lang="en-US"/>
               <a:t>Second level</a:t>
             </a:r>
           </a:p>
           <a:p>
             <a:pPr lvl="2"/>
             <a:r>
-              <a:rPr lang="en-US" smtClean="0"/>
+              <a:rPr lang="en-US"/>
               <a:t>Third level</a:t>
             </a:r>
           </a:p>
           <a:p>
             <a:pPr lvl="3"/>
             <a:r>
-              <a:rPr lang="en-US" smtClean="0"/>
+              <a:rPr lang="en-US"/>
               <a:t>Fourth level</a:t>
             </a:r>
           </a:p>
           <a:p>
             <a:pPr lvl="4"/>
             <a:r>
-              <a:rPr lang="en-US" smtClean="0"/>
+              <a:rPr lang="en-US"/>
               <a:t>Fifth level</a:t>
             </a:r>
-            <a:endParaRPr lang="en-US"/>
           </a:p>
         </p:txBody>
       </p:sp>
@@ -1786,7 +1787,7 @@
           <a:p>
             <a:fld id="{5BCAD085-E8A6-8845-BD4E-CB4CCA059FC4}" type="datetimeFigureOut">
               <a:rPr lang="en-US" smtClean="0"/>
-              <a:t>1/27/13</a:t>
+              <a:t>8/7/2026</a:t>
             </a:fld>
             <a:endParaRPr lang="en-US"/>
           </a:p>
@@ -1880,10 +1881,9 @@
           <a:lstStyle/>
           <a:p>
             <a:r>
-              <a:rPr lang="en-US" smtClean="0"/>
+              <a:rPr lang="en-US"/>
               <a:t>Click to edit Master title style</a:t>
             </a:r>
-            <a:endParaRPr lang="en-US"/>
           </a:p>
         </p:txBody>
       </p:sp>
@@ -1904,7 +1904,7 @@
           <a:p>
             <a:fld id="{5BCAD085-E8A6-8845-BD4E-CB4CCA059FC4}" type="datetimeFigureOut">
               <a:rPr lang="en-US" smtClean="0"/>
-              <a:t>1/27/13</a:t>
+              <a:t>8/7/2026</a:t>
             </a:fld>
             <a:endParaRPr lang="en-US"/>
           </a:p>
@@ -1999,7 +1999,7 @@
           <a:p>
             <a:fld id="{5BCAD085-E8A6-8845-BD4E-CB4CCA059FC4}" type="datetimeFigureOut">
               <a:rPr lang="en-US" smtClean="0"/>
-              <a:t>1/27/13</a:t>
+              <a:t>8/7/2026</a:t>
             </a:fld>
             <a:endParaRPr lang="en-US"/>
           </a:p>
@@ -2102,10 +2102,9 @@
           </a:lstStyle>
           <a:p>
             <a:r>
-              <a:rPr lang="en-US" smtClean="0"/>
+              <a:rPr lang="en-US"/>
               <a:t>Click to edit Master title style</a:t>
             </a:r>
-            <a:endParaRPr lang="en-US"/>
           </a:p>
         </p:txBody>
       </p:sp>
@@ -2159,38 +2158,37 @@
           <a:p>
             <a:pPr lvl="0"/>
             <a:r>
-              <a:rPr lang="en-US" smtClean="0"/>
+              <a:rPr lang="en-US"/>
               <a:t>Click to edit Master text styles</a:t>
             </a:r>
           </a:p>
           <a:p>
             <a:pPr lvl="1"/>
             <a:r>
-              <a:rPr lang="en-US" smtClean="0"/>
+              <a:rPr lang="en-US"/>
               <a:t>Second level</a:t>
             </a:r>
           </a:p>
           <a:p>
             <a:pPr lvl="2"/>
             <a:r>
-              <a:rPr lang="en-US" smtClean="0"/>
+              <a:rPr lang="en-US"/>
               <a:t>Third level</a:t>
             </a:r>
           </a:p>
           <a:p>
             <a:pPr lvl="3"/>
             <a:r>
-              <a:rPr lang="en-US" smtClean="0"/>
+              <a:rPr lang="en-US"/>
               <a:t>Fourth level</a:t>
             </a:r>
           </a:p>
           <a:p>
             <a:pPr lvl="4"/>
             <a:r>
-              <a:rPr lang="en-US" smtClean="0"/>
+              <a:rPr lang="en-US"/>
               <a:t>Fifth level</a:t>
             </a:r>
-            <a:endParaRPr lang="en-US"/>
           </a:p>
         </p:txBody>
       </p:sp>
@@ -2253,7 +2251,7 @@
           <a:p>
             <a:pPr lvl="0"/>
             <a:r>
-              <a:rPr lang="en-US" smtClean="0"/>
+              <a:rPr lang="en-US"/>
               <a:t>Click to edit Master text styles</a:t>
             </a:r>
           </a:p>
@@ -2276,7 +2274,7 @@
           <a:p>
             <a:fld id="{5BCAD085-E8A6-8845-BD4E-CB4CCA059FC4}" type="datetimeFigureOut">
               <a:rPr lang="en-US" smtClean="0"/>
-              <a:t>1/27/13</a:t>
+              <a:t>8/7/2026</a:t>
             </a:fld>
             <a:endParaRPr lang="en-US"/>
           </a:p>
@@ -2379,10 +2377,9 @@
           </a:lstStyle>
           <a:p>
             <a:r>
-              <a:rPr lang="en-US" smtClean="0"/>
+              <a:rPr lang="en-US"/>
               <a:t>Click to edit Master title style</a:t>
             </a:r>
-            <a:endParaRPr lang="en-US"/>
           </a:p>
         </p:txBody>
       </p:sp>
@@ -2506,7 +2503,7 @@
           <a:p>
             <a:pPr lvl="0"/>
             <a:r>
-              <a:rPr lang="en-US" smtClean="0"/>
+              <a:rPr lang="en-US"/>
               <a:t>Click to edit Master text styles</a:t>
             </a:r>
           </a:p>
@@ -2529,7 +2526,7 @@
           <a:p>
             <a:fld id="{5BCAD085-E8A6-8845-BD4E-CB4CCA059FC4}" type="datetimeFigureOut">
               <a:rPr lang="en-US" smtClean="0"/>
-              <a:t>1/27/13</a:t>
+              <a:t>8/7/2026</a:t>
             </a:fld>
             <a:endParaRPr lang="en-US"/>
           </a:p>
@@ -2638,10 +2635,9 @@
           <a:lstStyle/>
           <a:p>
             <a:r>
-              <a:rPr lang="en-US" smtClean="0"/>
+              <a:rPr lang="en-US"/>
               <a:t>Click to edit Master title style</a:t>
             </a:r>
-            <a:endParaRPr lang="en-US"/>
           </a:p>
         </p:txBody>
       </p:sp>
@@ -2672,38 +2668,37 @@
           <a:p>
             <a:pPr lvl="0"/>
             <a:r>
-              <a:rPr lang="en-US" smtClean="0"/>
+              <a:rPr lang="en-US"/>
               <a:t>Click to edit Master text styles</a:t>
             </a:r>
           </a:p>
           <a:p>
             <a:pPr lvl="1"/>
             <a:r>
-              <a:rPr lang="en-US" smtClean="0"/>
+              <a:rPr lang="en-US"/>
               <a:t>Second level</a:t>
             </a:r>
           </a:p>
           <a:p>
             <a:pPr lvl="2"/>
             <a:r>
-              <a:rPr lang="en-US" smtClean="0"/>
+              <a:rPr lang="en-US"/>
               <a:t>Third level</a:t>
             </a:r>
           </a:p>
           <a:p>
             <a:pPr lvl="3"/>
             <a:r>
-              <a:rPr lang="en-US" smtClean="0"/>
+              <a:rPr lang="en-US"/>
               <a:t>Fourth level</a:t>
             </a:r>
           </a:p>
           <a:p>
             <a:pPr lvl="4"/>
             <a:r>
-              <a:rPr lang="en-US" smtClean="0"/>
+              <a:rPr lang="en-US"/>
               <a:t>Fifth level</a:t>
             </a:r>
-            <a:endParaRPr lang="en-US"/>
           </a:p>
         </p:txBody>
       </p:sp>
@@ -2742,7 +2737,7 @@
           <a:p>
             <a:fld id="{5BCAD085-E8A6-8845-BD4E-CB4CCA059FC4}" type="datetimeFigureOut">
               <a:rPr lang="en-US" smtClean="0"/>
-              <a:t>1/27/13</a:t>
+              <a:t>8/7/2026</a:t>
             </a:fld>
             <a:endParaRPr lang="en-US"/>
           </a:p>
@@ -3101,7 +3096,7 @@
 </file>
 
 <file path=ppt/slides/slide1.xml><?xml version="1.0" encoding="utf-8"?>
-<p:sld xmlns:a="http://schemas.openxmlformats.org/drawingml/2006/main" xmlns:p="http://schemas.openxmlformats.org/presentationml/2006/main" xmlns:r="http://schemas.openxmlformats.org/officeDocument/2006/relationships">
+<p:sld xmlns:a="http://schemas.openxmlformats.org/drawingml/2006/main" xmlns:r="http://schemas.openxmlformats.org/officeDocument/2006/relationships" xmlns:p="http://schemas.openxmlformats.org/presentationml/2006/main">
   <p:cSld>
     <p:bg>
       <p:bgPr>
@@ -3117,7 +3112,14 @@
         <p:cNvGrpSpPr/>
         <p:nvPr/>
       </p:nvGrpSpPr>
-      <p:grpSpPr/>
+      <p:grpSpPr>
+        <a:xfrm>
+          <a:off x="0" y="0"/>
+          <a:ext cx="0" cy="0"/>
+          <a:chOff x="0" y="0"/>
+          <a:chExt cx="0" cy="0"/>
+        </a:xfrm>
+      </p:grpSpPr>
       <p:sp>
         <p:nvSpPr>
           <p:cNvPr id="2" name="TextBox 1"/>
@@ -3589,36 +3591,42 @@
         <p:spPr>
           <a:xfrm>
             <a:off x="822960" y="5074920"/>
-            <a:ext cx="10058400" cy="457200"/>
-          </a:xfrm>
-          <a:prstGeom prst="rect">
-            <a:avLst/>
-          </a:prstGeom>
-          <a:noFill/>
-        </p:spPr>
-        <p:txBody>
-          <a:bodyPr wrap="square">
-            <a:spAutoFit/>
-          </a:bodyPr>
-          <a:lstStyle/>
-          <a:p>
-            <a:pPr algn="l">
-              <a:spcBef>
-                <a:spcPts val="0"/>
-              </a:spcBef>
-              <a:spcAft>
-                <a:spcPts val="0"/>
-              </a:spcAft>
-            </a:pPr>
-            <a:r>
-              <a:rPr sz="1300" b="0">
+            <a:ext cx="10058400" cy="292388"/>
+          </a:xfrm>
+          <a:prstGeom prst="rect">
+            <a:avLst/>
+          </a:prstGeom>
+          <a:noFill/>
+        </p:spPr>
+        <p:txBody>
+          <a:bodyPr wrap="square">
+            <a:spAutoFit/>
+          </a:bodyPr>
+          <a:lstStyle/>
+          <a:p>
+            <a:pPr algn="l">
+              <a:spcBef>
+                <a:spcPts val="0"/>
+              </a:spcBef>
+              <a:spcAft>
+                <a:spcPts val="0"/>
+              </a:spcAft>
+            </a:pPr>
+            <a:r>
+              <a:rPr lang="en-US" sz="1300" b="0">
                 <a:solidFill>
                   <a:srgbClr val="8895A7"/>
                 </a:solidFill>
                 <a:latin typeface="Calibri"/>
               </a:rPr>
-              <a:t>Fully local and offline for demos 1-2 -- Groq only appears in a short bonus preview of Lecture 3</a:t>
-            </a:r>
+              <a:t>Fully local and offline -- no API key needed for any of the three demos</a:t>
+            </a:r>
+            <a:endParaRPr sz="1300" b="0">
+              <a:solidFill>
+                <a:srgbClr val="8895A7"/>
+              </a:solidFill>
+              <a:latin typeface="Calibri"/>
+            </a:endParaRPr>
           </a:p>
         </p:txBody>
       </p:sp>
@@ -3673,7 +3681,7 @@
 </file>
 
 <file path=ppt/slides/slide10.xml><?xml version="1.0" encoding="utf-8"?>
-<p:sld xmlns:a="http://schemas.openxmlformats.org/drawingml/2006/main" xmlns:p="http://schemas.openxmlformats.org/presentationml/2006/main" xmlns:r="http://schemas.openxmlformats.org/officeDocument/2006/relationships">
+<p:sld xmlns:a="http://schemas.openxmlformats.org/drawingml/2006/main" xmlns:r="http://schemas.openxmlformats.org/officeDocument/2006/relationships" xmlns:p="http://schemas.openxmlformats.org/presentationml/2006/main">
   <p:cSld>
     <p:bg>
       <p:bgPr>
@@ -3689,7 +3697,14 @@
         <p:cNvGrpSpPr/>
         <p:nvPr/>
       </p:nvGrpSpPr>
-      <p:grpSpPr/>
+      <p:grpSpPr>
+        <a:xfrm>
+          <a:off x="0" y="0"/>
+          <a:ext cx="0" cy="0"/>
+          <a:chOff x="0" y="0"/>
+          <a:chExt cx="0" cy="0"/>
+        </a:xfrm>
+      </p:grpSpPr>
       <p:sp>
         <p:nvSpPr>
           <p:cNvPr id="2" name="TextBox 1"/>
@@ -3867,7 +3882,7 @@
 </file>
 
 <file path=ppt/slides/slide11.xml><?xml version="1.0" encoding="utf-8"?>
-<p:sld xmlns:a="http://schemas.openxmlformats.org/drawingml/2006/main" xmlns:p="http://schemas.openxmlformats.org/presentationml/2006/main" xmlns:r="http://schemas.openxmlformats.org/officeDocument/2006/relationships">
+<p:sld xmlns:a="http://schemas.openxmlformats.org/drawingml/2006/main" xmlns:r="http://schemas.openxmlformats.org/officeDocument/2006/relationships" xmlns:p="http://schemas.openxmlformats.org/presentationml/2006/main">
   <p:cSld>
     <p:bg>
       <p:bgPr>
@@ -3883,7 +3898,14 @@
         <p:cNvGrpSpPr/>
         <p:nvPr/>
       </p:nvGrpSpPr>
-      <p:grpSpPr/>
+      <p:grpSpPr>
+        <a:xfrm>
+          <a:off x="0" y="0"/>
+          <a:ext cx="0" cy="0"/>
+          <a:chOff x="0" y="0"/>
+          <a:chExt cx="0" cy="0"/>
+        </a:xfrm>
+      </p:grpSpPr>
       <p:sp>
         <p:nvSpPr>
           <p:cNvPr id="2" name="TextBox 1"/>
@@ -4051,6 +4073,7 @@
           <a:lstStyle/>
           <a:p>
             <a:pPr algn="ctr"/>
+            <a:endParaRPr/>
           </a:p>
         </p:txBody>
       </p:sp>
@@ -4137,6 +4160,7 @@
           <a:lstStyle/>
           <a:p>
             <a:pPr algn="ctr"/>
+            <a:endParaRPr/>
           </a:p>
         </p:txBody>
       </p:sp>
@@ -4189,15 +4213,12 @@
                 <a:spcPts val="0"/>
               </a:spcAft>
             </a:pPr>
-            <a:r>
-              <a:rPr sz="1300" b="0">
-                <a:solidFill>
-                  <a:srgbClr val="CADCFC"/>
-                </a:solidFill>
-                <a:latin typeface="Courier New"/>
-              </a:rPr>
-              <a:t/>
-            </a:r>
+            <a:endParaRPr sz="1300" b="0">
+              <a:solidFill>
+                <a:srgbClr val="CADCFC"/>
+              </a:solidFill>
+              <a:latin typeface="Courier New"/>
+            </a:endParaRPr>
           </a:p>
           <a:p>
             <a:pPr>
@@ -4290,7 +4311,7 @@
 </file>
 
 <file path=ppt/slides/slide12.xml><?xml version="1.0" encoding="utf-8"?>
-<p:sld xmlns:a="http://schemas.openxmlformats.org/drawingml/2006/main" xmlns:p="http://schemas.openxmlformats.org/presentationml/2006/main" xmlns:r="http://schemas.openxmlformats.org/officeDocument/2006/relationships">
+<p:sld xmlns:a="http://schemas.openxmlformats.org/drawingml/2006/main" xmlns:r="http://schemas.openxmlformats.org/officeDocument/2006/relationships" xmlns:p="http://schemas.openxmlformats.org/presentationml/2006/main">
   <p:cSld>
     <p:bg>
       <p:bgPr>
@@ -4306,7 +4327,14 @@
         <p:cNvGrpSpPr/>
         <p:nvPr/>
       </p:nvGrpSpPr>
-      <p:grpSpPr/>
+      <p:grpSpPr>
+        <a:xfrm>
+          <a:off x="0" y="0"/>
+          <a:ext cx="0" cy="0"/>
+          <a:chOff x="0" y="0"/>
+          <a:chExt cx="0" cy="0"/>
+        </a:xfrm>
+      </p:grpSpPr>
       <p:sp>
         <p:nvSpPr>
           <p:cNvPr id="2" name="TextBox 1"/>
@@ -4990,7 +5018,7 @@
 </file>
 
 <file path=ppt/slides/slide13.xml><?xml version="1.0" encoding="utf-8"?>
-<p:sld xmlns:a="http://schemas.openxmlformats.org/drawingml/2006/main" xmlns:p="http://schemas.openxmlformats.org/presentationml/2006/main" xmlns:r="http://schemas.openxmlformats.org/officeDocument/2006/relationships">
+<p:sld xmlns:a="http://schemas.openxmlformats.org/drawingml/2006/main" xmlns:r="http://schemas.openxmlformats.org/officeDocument/2006/relationships" xmlns:p="http://schemas.openxmlformats.org/presentationml/2006/main">
   <p:cSld>
     <p:bg>
       <p:bgPr>
@@ -5006,7 +5034,14 @@
         <p:cNvGrpSpPr/>
         <p:nvPr/>
       </p:nvGrpSpPr>
-      <p:grpSpPr/>
+      <p:grpSpPr>
+        <a:xfrm>
+          <a:off x="0" y="0"/>
+          <a:ext cx="0" cy="0"/>
+          <a:chOff x="0" y="0"/>
+          <a:chExt cx="0" cy="0"/>
+        </a:xfrm>
+      </p:grpSpPr>
       <p:sp>
         <p:nvSpPr>
           <p:cNvPr id="2" name="TextBox 1"/>
@@ -5174,6 +5209,7 @@
           <a:lstStyle/>
           <a:p>
             <a:pPr algn="ctr"/>
+            <a:endParaRPr/>
           </a:p>
         </p:txBody>
       </p:sp>
@@ -5287,15 +5323,12 @@
                 <a:spcPts val="0"/>
               </a:spcAft>
             </a:pPr>
-            <a:r>
-              <a:rPr sz="1400" b="0">
-                <a:solidFill>
-                  <a:srgbClr val="0E1B2B"/>
-                </a:solidFill>
-                <a:latin typeface="Calibri"/>
-              </a:rPr>
-              <a:t/>
-            </a:r>
+            <a:endParaRPr sz="1400" b="0">
+              <a:solidFill>
+                <a:srgbClr val="0E1B2B"/>
+              </a:solidFill>
+              <a:latin typeface="Calibri"/>
+            </a:endParaRPr>
           </a:p>
           <a:p>
             <a:pPr algn="l">
@@ -5359,6 +5392,7 @@
           <a:lstStyle/>
           <a:p>
             <a:pPr algn="ctr"/>
+            <a:endParaRPr/>
           </a:p>
         </p:txBody>
       </p:sp>
@@ -5472,15 +5506,12 @@
                 <a:spcPts val="0"/>
               </a:spcAft>
             </a:pPr>
-            <a:r>
-              <a:rPr sz="1400" b="0">
-                <a:solidFill>
-                  <a:srgbClr val="FFFFFF"/>
-                </a:solidFill>
-                <a:latin typeface="Calibri"/>
-              </a:rPr>
-              <a:t/>
-            </a:r>
+            <a:endParaRPr sz="1400" b="0">
+              <a:solidFill>
+                <a:srgbClr val="FFFFFF"/>
+              </a:solidFill>
+              <a:latin typeface="Calibri"/>
+            </a:endParaRPr>
           </a:p>
           <a:p>
             <a:pPr algn="l">
@@ -5554,7 +5585,7 @@
 </file>
 
 <file path=ppt/slides/slide14.xml><?xml version="1.0" encoding="utf-8"?>
-<p:sld xmlns:a="http://schemas.openxmlformats.org/drawingml/2006/main" xmlns:p="http://schemas.openxmlformats.org/presentationml/2006/main" xmlns:r="http://schemas.openxmlformats.org/officeDocument/2006/relationships">
+<p:sld xmlns:a="http://schemas.openxmlformats.org/drawingml/2006/main" xmlns:r="http://schemas.openxmlformats.org/officeDocument/2006/relationships" xmlns:p="http://schemas.openxmlformats.org/presentationml/2006/main">
   <p:cSld>
     <p:bg>
       <p:bgPr>
@@ -5570,7 +5601,14 @@
         <p:cNvGrpSpPr/>
         <p:nvPr/>
       </p:nvGrpSpPr>
-      <p:grpSpPr/>
+      <p:grpSpPr>
+        <a:xfrm>
+          <a:off x="0" y="0"/>
+          <a:ext cx="0" cy="0"/>
+          <a:chOff x="0" y="0"/>
+          <a:chExt cx="0" cy="0"/>
+        </a:xfrm>
+      </p:grpSpPr>
       <p:sp>
         <p:nvSpPr>
           <p:cNvPr id="2" name="TextBox 1"/>
@@ -5748,7 +5786,7 @@
 </file>
 
 <file path=ppt/slides/slide15.xml><?xml version="1.0" encoding="utf-8"?>
-<p:sld xmlns:a="http://schemas.openxmlformats.org/drawingml/2006/main" xmlns:p="http://schemas.openxmlformats.org/presentationml/2006/main" xmlns:r="http://schemas.openxmlformats.org/officeDocument/2006/relationships">
+<p:sld xmlns:a="http://schemas.openxmlformats.org/drawingml/2006/main" xmlns:r="http://schemas.openxmlformats.org/officeDocument/2006/relationships" xmlns:p="http://schemas.openxmlformats.org/presentationml/2006/main">
   <p:cSld>
     <p:bg>
       <p:bgPr>
@@ -5764,7 +5802,14 @@
         <p:cNvGrpSpPr/>
         <p:nvPr/>
       </p:nvGrpSpPr>
-      <p:grpSpPr/>
+      <p:grpSpPr>
+        <a:xfrm>
+          <a:off x="0" y="0"/>
+          <a:ext cx="0" cy="0"/>
+          <a:chOff x="0" y="0"/>
+          <a:chExt cx="0" cy="0"/>
+        </a:xfrm>
+      </p:grpSpPr>
       <p:sp>
         <p:nvSpPr>
           <p:cNvPr id="2" name="TextBox 1"/>
@@ -5932,6 +5977,7 @@
           <a:lstStyle/>
           <a:p>
             <a:pPr algn="ctr"/>
+            <a:endParaRPr/>
           </a:p>
         </p:txBody>
       </p:sp>
@@ -6018,6 +6064,7 @@
           <a:lstStyle/>
           <a:p>
             <a:pPr algn="ctr"/>
+            <a:endParaRPr/>
           </a:p>
         </p:txBody>
       </p:sp>
@@ -6089,14 +6136,30 @@
                 <a:spcPts val="0"/>
               </a:spcAft>
             </a:pPr>
+            <a:endParaRPr sz="1300" b="0">
+              <a:solidFill>
+                <a:srgbClr val="CADCFC"/>
+              </a:solidFill>
+              <a:latin typeface="Courier New"/>
+            </a:endParaRPr>
+          </a:p>
+          <a:p>
+            <a:pPr>
+              <a:spcBef>
+                <a:spcPts val="0"/>
+              </a:spcBef>
+              <a:spcAft>
+                <a:spcPts val="0"/>
+              </a:spcAft>
+            </a:pPr>
             <a:r>
               <a:rPr sz="1300" b="0">
                 <a:solidFill>
-                  <a:srgbClr val="CADCFC"/>
+                  <a:srgbClr val="8895A7"/>
                 </a:solidFill>
                 <a:latin typeface="Courier New"/>
               </a:rPr>
-              <a:t/>
+              <a:t># Persistent -- backed by real files, survives a restart</a:t>
             </a:r>
           </a:p>
           <a:p>
@@ -6109,13 +6172,13 @@
               </a:spcAft>
             </a:pPr>
             <a:r>
-              <a:rPr sz="1300" b="0">
-                <a:solidFill>
-                  <a:srgbClr val="8895A7"/>
+              <a:rPr sz="1300" b="1">
+                <a:solidFill>
+                  <a:srgbClr val="E8A33D"/>
                 </a:solidFill>
                 <a:latin typeface="Courier New"/>
               </a:rPr>
-              <a:t># Persistent -- backed by real files, survives a restart</a:t>
+              <a:t>client = chromadb.PersistentClient(path="./chroma_store")</a:t>
             </a:r>
           </a:p>
           <a:p>
@@ -6127,34 +6190,12 @@
                 <a:spcPts val="0"/>
               </a:spcAft>
             </a:pPr>
-            <a:r>
-              <a:rPr sz="1300" b="1">
-                <a:solidFill>
-                  <a:srgbClr val="E8A33D"/>
-                </a:solidFill>
-                <a:latin typeface="Courier New"/>
-              </a:rPr>
-              <a:t>client = chromadb.PersistentClient(path="./chroma_store")</a:t>
-            </a:r>
-          </a:p>
-          <a:p>
-            <a:pPr>
-              <a:spcBef>
-                <a:spcPts val="0"/>
-              </a:spcBef>
-              <a:spcAft>
-                <a:spcPts val="0"/>
-              </a:spcAft>
-            </a:pPr>
-            <a:r>
-              <a:rPr sz="1300" b="0">
-                <a:solidFill>
-                  <a:srgbClr val="CADCFC"/>
-                </a:solidFill>
-                <a:latin typeface="Courier New"/>
-              </a:rPr>
-              <a:t/>
-            </a:r>
+            <a:endParaRPr sz="1300" b="1">
+              <a:solidFill>
+                <a:srgbClr val="E8A33D"/>
+              </a:solidFill>
+              <a:latin typeface="Courier New"/>
+            </a:endParaRPr>
           </a:p>
           <a:p>
             <a:pPr>
@@ -6186,7 +6227,7 @@
 </file>
 
 <file path=ppt/slides/slide16.xml><?xml version="1.0" encoding="utf-8"?>
-<p:sld xmlns:a="http://schemas.openxmlformats.org/drawingml/2006/main" xmlns:p="http://schemas.openxmlformats.org/presentationml/2006/main" xmlns:r="http://schemas.openxmlformats.org/officeDocument/2006/relationships">
+<p:sld xmlns:a="http://schemas.openxmlformats.org/drawingml/2006/main" xmlns:r="http://schemas.openxmlformats.org/officeDocument/2006/relationships" xmlns:p="http://schemas.openxmlformats.org/presentationml/2006/main">
   <p:cSld>
     <p:bg>
       <p:bgPr>
@@ -6202,7 +6243,14 @@
         <p:cNvGrpSpPr/>
         <p:nvPr/>
       </p:nvGrpSpPr>
-      <p:grpSpPr/>
+      <p:grpSpPr>
+        <a:xfrm>
+          <a:off x="0" y="0"/>
+          <a:ext cx="0" cy="0"/>
+          <a:chOff x="0" y="0"/>
+          <a:chExt cx="0" cy="0"/>
+        </a:xfrm>
+      </p:grpSpPr>
       <p:sp>
         <p:nvSpPr>
           <p:cNvPr id="2" name="TextBox 1"/>
@@ -6370,6 +6418,7 @@
           <a:lstStyle/>
           <a:p>
             <a:pPr algn="ctr"/>
+            <a:endParaRPr/>
           </a:p>
         </p:txBody>
       </p:sp>
@@ -6464,15 +6513,12 @@
                 <a:spcPts val="0"/>
               </a:spcAft>
             </a:pPr>
-            <a:r>
-              <a:rPr sz="1400" b="0">
-                <a:solidFill>
-                  <a:srgbClr val="0E1B2B"/>
-                </a:solidFill>
-                <a:latin typeface="Calibri"/>
-              </a:rPr>
-              <a:t/>
-            </a:r>
+            <a:endParaRPr sz="1400" b="0">
+              <a:solidFill>
+                <a:srgbClr val="0E1B2B"/>
+              </a:solidFill>
+              <a:latin typeface="Calibri"/>
+            </a:endParaRPr>
           </a:p>
           <a:p>
             <a:pPr algn="l">
@@ -6536,6 +6582,7 @@
           <a:lstStyle/>
           <a:p>
             <a:pPr algn="ctr"/>
+            <a:endParaRPr/>
           </a:p>
         </p:txBody>
       </p:sp>
@@ -6630,15 +6677,12 @@
                 <a:spcPts val="0"/>
               </a:spcAft>
             </a:pPr>
-            <a:r>
-              <a:rPr sz="1400" b="0">
-                <a:solidFill>
-                  <a:srgbClr val="FFFFFF"/>
-                </a:solidFill>
-                <a:latin typeface="Calibri"/>
-              </a:rPr>
-              <a:t/>
-            </a:r>
+            <a:endParaRPr sz="1400" b="0">
+              <a:solidFill>
+                <a:srgbClr val="FFFFFF"/>
+              </a:solidFill>
+              <a:latin typeface="Calibri"/>
+            </a:endParaRPr>
           </a:p>
           <a:p>
             <a:pPr algn="l">
@@ -6670,7 +6714,7 @@
 </file>
 
 <file path=ppt/slides/slide17.xml><?xml version="1.0" encoding="utf-8"?>
-<p:sld xmlns:a="http://schemas.openxmlformats.org/drawingml/2006/main" xmlns:p="http://schemas.openxmlformats.org/presentationml/2006/main" xmlns:r="http://schemas.openxmlformats.org/officeDocument/2006/relationships">
+<p:sld xmlns:a="http://schemas.openxmlformats.org/drawingml/2006/main" xmlns:r="http://schemas.openxmlformats.org/officeDocument/2006/relationships" xmlns:p="http://schemas.openxmlformats.org/presentationml/2006/main">
   <p:cSld>
     <p:bg>
       <p:bgPr>
@@ -6686,7 +6730,14 @@
         <p:cNvGrpSpPr/>
         <p:nvPr/>
       </p:nvGrpSpPr>
-      <p:grpSpPr/>
+      <p:grpSpPr>
+        <a:xfrm>
+          <a:off x="0" y="0"/>
+          <a:ext cx="0" cy="0"/>
+          <a:chOff x="0" y="0"/>
+          <a:chExt cx="0" cy="0"/>
+        </a:xfrm>
+      </p:grpSpPr>
       <p:sp>
         <p:nvSpPr>
           <p:cNvPr id="2" name="TextBox 1"/>
@@ -6864,7 +6915,7 @@
 </file>
 
 <file path=ppt/slides/slide18.xml><?xml version="1.0" encoding="utf-8"?>
-<p:sld xmlns:a="http://schemas.openxmlformats.org/drawingml/2006/main" xmlns:p="http://schemas.openxmlformats.org/presentationml/2006/main" xmlns:r="http://schemas.openxmlformats.org/officeDocument/2006/relationships">
+<p:sld xmlns:a="http://schemas.openxmlformats.org/drawingml/2006/main" xmlns:r="http://schemas.openxmlformats.org/officeDocument/2006/relationships" xmlns:p="http://schemas.openxmlformats.org/presentationml/2006/main">
   <p:cSld>
     <p:bg>
       <p:bgPr>
@@ -6880,7 +6931,14 @@
         <p:cNvGrpSpPr/>
         <p:nvPr/>
       </p:nvGrpSpPr>
-      <p:grpSpPr/>
+      <p:grpSpPr>
+        <a:xfrm>
+          <a:off x="0" y="0"/>
+          <a:ext cx="0" cy="0"/>
+          <a:chOff x="0" y="0"/>
+          <a:chExt cx="0" cy="0"/>
+        </a:xfrm>
+      </p:grpSpPr>
       <p:sp>
         <p:nvSpPr>
           <p:cNvPr id="2" name="TextBox 1"/>
@@ -7132,6 +7190,7 @@
           <a:lstStyle/>
           <a:p>
             <a:pPr algn="ctr"/>
+            <a:endParaRPr/>
           </a:p>
         </p:txBody>
       </p:sp>
@@ -7218,6 +7277,7 @@
           <a:lstStyle/>
           <a:p>
             <a:pPr algn="ctr"/>
+            <a:endParaRPr/>
           </a:p>
         </p:txBody>
       </p:sp>
@@ -7304,6 +7364,7 @@
           <a:lstStyle/>
           <a:p>
             <a:pPr algn="ctr"/>
+            <a:endParaRPr/>
           </a:p>
         </p:txBody>
       </p:sp>
@@ -7390,6 +7451,7 @@
           <a:lstStyle/>
           <a:p>
             <a:pPr algn="ctr"/>
+            <a:endParaRPr/>
           </a:p>
         </p:txBody>
       </p:sp>
@@ -7476,6 +7538,7 @@
           <a:lstStyle/>
           <a:p>
             <a:pPr algn="ctr"/>
+            <a:endParaRPr/>
           </a:p>
         </p:txBody>
       </p:sp>
@@ -7562,6 +7625,7 @@
           <a:lstStyle/>
           <a:p>
             <a:pPr algn="ctr"/>
+            <a:endParaRPr/>
           </a:p>
         </p:txBody>
       </p:sp>
@@ -7616,7 +7680,7 @@
 </file>
 
 <file path=ppt/slides/slide19.xml><?xml version="1.0" encoding="utf-8"?>
-<p:sld xmlns:a="http://schemas.openxmlformats.org/drawingml/2006/main" xmlns:p="http://schemas.openxmlformats.org/presentationml/2006/main" xmlns:r="http://schemas.openxmlformats.org/officeDocument/2006/relationships">
+<p:sld xmlns:a="http://schemas.openxmlformats.org/drawingml/2006/main" xmlns:r="http://schemas.openxmlformats.org/officeDocument/2006/relationships" xmlns:p="http://schemas.openxmlformats.org/presentationml/2006/main">
   <p:cSld>
     <p:bg>
       <p:bgPr>
@@ -7632,7 +7696,14 @@
         <p:cNvGrpSpPr/>
         <p:nvPr/>
       </p:nvGrpSpPr>
-      <p:grpSpPr/>
+      <p:grpSpPr>
+        <a:xfrm>
+          <a:off x="0" y="0"/>
+          <a:ext cx="0" cy="0"/>
+          <a:chOff x="0" y="0"/>
+          <a:chExt cx="0" cy="0"/>
+        </a:xfrm>
+      </p:grpSpPr>
       <p:sp>
         <p:nvSpPr>
           <p:cNvPr id="2" name="TextBox 1"/>
@@ -7800,6 +7871,7 @@
           <a:lstStyle/>
           <a:p>
             <a:pPr algn="ctr"/>
+            <a:endParaRPr/>
           </a:p>
         </p:txBody>
       </p:sp>
@@ -7894,15 +7966,12 @@
                 <a:spcPts val="0"/>
               </a:spcAft>
             </a:pPr>
-            <a:r>
-              <a:rPr sz="1400" b="0">
-                <a:solidFill>
-                  <a:srgbClr val="0E1B2B"/>
-                </a:solidFill>
-                <a:latin typeface="Calibri"/>
-              </a:rPr>
-              <a:t/>
-            </a:r>
+            <a:endParaRPr sz="1400" b="0">
+              <a:solidFill>
+                <a:srgbClr val="0E1B2B"/>
+              </a:solidFill>
+              <a:latin typeface="Calibri"/>
+            </a:endParaRPr>
           </a:p>
           <a:p>
             <a:pPr algn="l">
@@ -7966,6 +8035,7 @@
           <a:lstStyle/>
           <a:p>
             <a:pPr algn="ctr"/>
+            <a:endParaRPr/>
           </a:p>
         </p:txBody>
       </p:sp>
@@ -8060,15 +8130,12 @@
                 <a:spcPts val="0"/>
               </a:spcAft>
             </a:pPr>
-            <a:r>
-              <a:rPr sz="1400" b="0">
-                <a:solidFill>
-                  <a:srgbClr val="FFFFFF"/>
-                </a:solidFill>
-                <a:latin typeface="Calibri"/>
-              </a:rPr>
-              <a:t/>
-            </a:r>
+            <a:endParaRPr sz="1400" b="0">
+              <a:solidFill>
+                <a:srgbClr val="FFFFFF"/>
+              </a:solidFill>
+              <a:latin typeface="Calibri"/>
+            </a:endParaRPr>
           </a:p>
           <a:p>
             <a:pPr algn="l">
@@ -8100,7 +8167,7 @@
 </file>
 
 <file path=ppt/slides/slide2.xml><?xml version="1.0" encoding="utf-8"?>
-<p:sld xmlns:a="http://schemas.openxmlformats.org/drawingml/2006/main" xmlns:p="http://schemas.openxmlformats.org/presentationml/2006/main" xmlns:r="http://schemas.openxmlformats.org/officeDocument/2006/relationships">
+<p:sld xmlns:a="http://schemas.openxmlformats.org/drawingml/2006/main" xmlns:r="http://schemas.openxmlformats.org/officeDocument/2006/relationships" xmlns:p="http://schemas.openxmlformats.org/presentationml/2006/main">
   <p:cSld>
     <p:bg>
       <p:bgPr>
@@ -8116,7 +8183,14 @@
         <p:cNvGrpSpPr/>
         <p:nvPr/>
       </p:nvGrpSpPr>
-      <p:grpSpPr/>
+      <p:grpSpPr>
+        <a:xfrm>
+          <a:off x="0" y="0"/>
+          <a:ext cx="0" cy="0"/>
+          <a:chOff x="0" y="0"/>
+          <a:chExt cx="0" cy="0"/>
+        </a:xfrm>
+      </p:grpSpPr>
       <p:sp>
         <p:nvSpPr>
           <p:cNvPr id="2" name="TextBox 1"/>
@@ -9074,7 +9148,7 @@
 </file>
 
 <file path=ppt/slides/slide20.xml><?xml version="1.0" encoding="utf-8"?>
-<p:sld xmlns:a="http://schemas.openxmlformats.org/drawingml/2006/main" xmlns:p="http://schemas.openxmlformats.org/presentationml/2006/main" xmlns:r="http://schemas.openxmlformats.org/officeDocument/2006/relationships">
+<p:sld xmlns:a="http://schemas.openxmlformats.org/drawingml/2006/main" xmlns:r="http://schemas.openxmlformats.org/officeDocument/2006/relationships" xmlns:p="http://schemas.openxmlformats.org/presentationml/2006/main">
   <p:cSld>
     <p:bg>
       <p:bgPr>
@@ -9090,7 +9164,14 @@
         <p:cNvGrpSpPr/>
         <p:nvPr/>
       </p:nvGrpSpPr>
-      <p:grpSpPr/>
+      <p:grpSpPr>
+        <a:xfrm>
+          <a:off x="0" y="0"/>
+          <a:ext cx="0" cy="0"/>
+          <a:chOff x="0" y="0"/>
+          <a:chExt cx="0" cy="0"/>
+        </a:xfrm>
+      </p:grpSpPr>
       <p:sp>
         <p:nvSpPr>
           <p:cNvPr id="2" name="TextBox 1"/>
@@ -9342,6 +9423,7 @@
           <a:lstStyle/>
           <a:p>
             <a:pPr algn="ctr"/>
+            <a:endParaRPr/>
           </a:p>
         </p:txBody>
       </p:sp>
@@ -9470,6 +9552,7 @@
           <a:lstStyle/>
           <a:p>
             <a:pPr algn="ctr"/>
+            <a:endParaRPr/>
           </a:p>
         </p:txBody>
       </p:sp>
@@ -9598,6 +9681,7 @@
           <a:lstStyle/>
           <a:p>
             <a:pPr algn="ctr"/>
+            <a:endParaRPr/>
           </a:p>
         </p:txBody>
       </p:sp>
@@ -9726,6 +9810,7 @@
           <a:lstStyle/>
           <a:p>
             <a:pPr algn="ctr"/>
+            <a:endParaRPr/>
           </a:p>
         </p:txBody>
       </p:sp>
@@ -9854,6 +9939,7 @@
           <a:lstStyle/>
           <a:p>
             <a:pPr algn="ctr"/>
+            <a:endParaRPr/>
           </a:p>
         </p:txBody>
       </p:sp>
@@ -9992,7 +10078,7 @@
 </file>
 
 <file path=ppt/slides/slide21.xml><?xml version="1.0" encoding="utf-8"?>
-<p:sld xmlns:a="http://schemas.openxmlformats.org/drawingml/2006/main" xmlns:p="http://schemas.openxmlformats.org/presentationml/2006/main" xmlns:r="http://schemas.openxmlformats.org/officeDocument/2006/relationships">
+<p:sld xmlns:a="http://schemas.openxmlformats.org/drawingml/2006/main" xmlns:r="http://schemas.openxmlformats.org/officeDocument/2006/relationships" xmlns:p="http://schemas.openxmlformats.org/presentationml/2006/main">
   <p:cSld>
     <p:bg>
       <p:bgPr>
@@ -10008,7 +10094,14 @@
         <p:cNvGrpSpPr/>
         <p:nvPr/>
       </p:nvGrpSpPr>
-      <p:grpSpPr/>
+      <p:grpSpPr>
+        <a:xfrm>
+          <a:off x="0" y="0"/>
+          <a:ext cx="0" cy="0"/>
+          <a:chOff x="0" y="0"/>
+          <a:chExt cx="0" cy="0"/>
+        </a:xfrm>
+      </p:grpSpPr>
       <p:sp>
         <p:nvSpPr>
           <p:cNvPr id="2" name="TextBox 1"/>
@@ -10471,36 +10564,42 @@
         <p:spPr>
           <a:xfrm>
             <a:off x="1600200" y="5093208"/>
-            <a:ext cx="8961120" cy="457200"/>
-          </a:xfrm>
-          <a:prstGeom prst="rect">
-            <a:avLst/>
-          </a:prstGeom>
-          <a:noFill/>
-        </p:spPr>
-        <p:txBody>
-          <a:bodyPr wrap="square">
-            <a:spAutoFit/>
-          </a:bodyPr>
-          <a:lstStyle/>
-          <a:p>
-            <a:pPr algn="l">
-              <a:spcBef>
-                <a:spcPts val="0"/>
-              </a:spcBef>
-              <a:spcAft>
-                <a:spcPts val="0"/>
-              </a:spcAft>
-            </a:pPr>
-            <a:r>
-              <a:rPr sz="1300" b="0">
+            <a:ext cx="8961120" cy="292388"/>
+          </a:xfrm>
+          <a:prstGeom prst="rect">
+            <a:avLst/>
+          </a:prstGeom>
+          <a:noFill/>
+        </p:spPr>
+        <p:txBody>
+          <a:bodyPr wrap="square">
+            <a:spAutoFit/>
+          </a:bodyPr>
+          <a:lstStyle/>
+          <a:p>
+            <a:pPr algn="l">
+              <a:spcBef>
+                <a:spcPts val="0"/>
+              </a:spcBef>
+              <a:spcAft>
+                <a:spcPts val="0"/>
+              </a:spcAft>
+            </a:pPr>
+            <a:r>
+              <a:rPr lang="en-US" sz="1300" b="0">
                 <a:solidFill>
                   <a:srgbClr val="CADCFC"/>
                 </a:solidFill>
                 <a:latin typeface="Calibri"/>
               </a:rPr>
-              <a:t>50-document knowledge base: semantic search vs. keyword search, plus a Groq RAG preview</a:t>
-            </a:r>
+              <a:t>50-document knowledge base: semantic search vs. keyword search</a:t>
+            </a:r>
+            <a:endParaRPr sz="1300" b="0">
+              <a:solidFill>
+                <a:srgbClr val="CADCFC"/>
+              </a:solidFill>
+              <a:latin typeface="Calibri"/>
+            </a:endParaRPr>
           </a:p>
         </p:txBody>
       </p:sp>
@@ -10555,7 +10654,7 @@
 </file>
 
 <file path=ppt/slides/slide22.xml><?xml version="1.0" encoding="utf-8"?>
-<p:sld xmlns:a="http://schemas.openxmlformats.org/drawingml/2006/main" xmlns:p="http://schemas.openxmlformats.org/presentationml/2006/main" xmlns:r="http://schemas.openxmlformats.org/officeDocument/2006/relationships">
+<p:sld xmlns:a="http://schemas.openxmlformats.org/drawingml/2006/main" xmlns:r="http://schemas.openxmlformats.org/officeDocument/2006/relationships" xmlns:p="http://schemas.openxmlformats.org/presentationml/2006/main">
   <p:cSld>
     <p:bg>
       <p:bgPr>
@@ -10571,7 +10670,14 @@
         <p:cNvGrpSpPr/>
         <p:nvPr/>
       </p:nvGrpSpPr>
-      <p:grpSpPr/>
+      <p:grpSpPr>
+        <a:xfrm>
+          <a:off x="0" y="0"/>
+          <a:ext cx="0" cy="0"/>
+          <a:chOff x="0" y="0"/>
+          <a:chExt cx="0" cy="0"/>
+        </a:xfrm>
+      </p:grpSpPr>
       <p:sp>
         <p:nvSpPr>
           <p:cNvPr id="2" name="TextBox 1"/>
@@ -10739,6 +10845,7 @@
           <a:lstStyle/>
           <a:p>
             <a:pPr algn="ctr"/>
+            <a:endParaRPr/>
           </a:p>
         </p:txBody>
       </p:sp>
@@ -10867,6 +10974,7 @@
           <a:lstStyle/>
           <a:p>
             <a:pPr algn="ctr"/>
+            <a:endParaRPr/>
           </a:p>
         </p:txBody>
       </p:sp>
@@ -10995,6 +11103,7 @@
           <a:lstStyle/>
           <a:p>
             <a:pPr algn="ctr"/>
+            <a:endParaRPr/>
           </a:p>
         </p:txBody>
       </p:sp>
@@ -11123,6 +11232,7 @@
           <a:lstStyle/>
           <a:p>
             <a:pPr algn="ctr"/>
+            <a:endParaRPr/>
           </a:p>
         </p:txBody>
       </p:sp>
@@ -11219,7 +11329,7 @@
 </file>
 
 <file path=ppt/slides/slide23.xml><?xml version="1.0" encoding="utf-8"?>
-<p:sld xmlns:a="http://schemas.openxmlformats.org/drawingml/2006/main" xmlns:p="http://schemas.openxmlformats.org/presentationml/2006/main" xmlns:r="http://schemas.openxmlformats.org/officeDocument/2006/relationships">
+<p:sld xmlns:a="http://schemas.openxmlformats.org/drawingml/2006/main" xmlns:r="http://schemas.openxmlformats.org/officeDocument/2006/relationships" xmlns:p="http://schemas.openxmlformats.org/presentationml/2006/main">
   <p:cSld>
     <p:bg>
       <p:bgPr>
@@ -11235,7 +11345,14 @@
         <p:cNvGrpSpPr/>
         <p:nvPr/>
       </p:nvGrpSpPr>
-      <p:grpSpPr/>
+      <p:grpSpPr>
+        <a:xfrm>
+          <a:off x="0" y="0"/>
+          <a:ext cx="0" cy="0"/>
+          <a:chOff x="0" y="0"/>
+          <a:chExt cx="0" cy="0"/>
+        </a:xfrm>
+      </p:grpSpPr>
       <p:sp>
         <p:nvSpPr>
           <p:cNvPr id="2" name="TextBox 1"/>
@@ -11498,6 +11615,7 @@
           <a:lstStyle/>
           <a:p>
             <a:pPr algn="ctr"/>
+            <a:endParaRPr/>
           </a:p>
         </p:txBody>
       </p:sp>
@@ -11594,7 +11712,7 @@
 </file>
 
 <file path=ppt/slides/slide3.xml><?xml version="1.0" encoding="utf-8"?>
-<p:sld xmlns:a="http://schemas.openxmlformats.org/drawingml/2006/main" xmlns:p="http://schemas.openxmlformats.org/presentationml/2006/main" xmlns:r="http://schemas.openxmlformats.org/officeDocument/2006/relationships">
+<p:sld xmlns:a="http://schemas.openxmlformats.org/drawingml/2006/main" xmlns:r="http://schemas.openxmlformats.org/officeDocument/2006/relationships" xmlns:p="http://schemas.openxmlformats.org/presentationml/2006/main">
   <p:cSld>
     <p:bg>
       <p:bgPr>
@@ -11610,7 +11728,14 @@
         <p:cNvGrpSpPr/>
         <p:nvPr/>
       </p:nvGrpSpPr>
-      <p:grpSpPr/>
+      <p:grpSpPr>
+        <a:xfrm>
+          <a:off x="0" y="0"/>
+          <a:ext cx="0" cy="0"/>
+          <a:chOff x="0" y="0"/>
+          <a:chExt cx="0" cy="0"/>
+        </a:xfrm>
+      </p:grpSpPr>
       <p:sp>
         <p:nvSpPr>
           <p:cNvPr id="2" name="TextBox 1"/>
@@ -11778,6 +11903,7 @@
           <a:lstStyle/>
           <a:p>
             <a:pPr algn="ctr"/>
+            <a:endParaRPr/>
           </a:p>
         </p:txBody>
       </p:sp>
@@ -11948,6 +12074,7 @@
           <a:lstStyle/>
           <a:p>
             <a:pPr algn="ctr"/>
+            <a:endParaRPr/>
           </a:p>
         </p:txBody>
       </p:sp>
@@ -12076,6 +12203,7 @@
           <a:lstStyle/>
           <a:p>
             <a:pPr algn="ctr"/>
+            <a:endParaRPr/>
           </a:p>
         </p:txBody>
       </p:sp>
@@ -12162,6 +12290,7 @@
           <a:lstStyle/>
           <a:p>
             <a:pPr algn="ctr"/>
+            <a:endParaRPr/>
           </a:p>
         </p:txBody>
       </p:sp>
@@ -12290,6 +12419,7 @@
           <a:lstStyle/>
           <a:p>
             <a:pPr algn="ctr"/>
+            <a:endParaRPr/>
           </a:p>
         </p:txBody>
       </p:sp>
@@ -12376,6 +12506,7 @@
           <a:lstStyle/>
           <a:p>
             <a:pPr algn="ctr"/>
+            <a:endParaRPr/>
           </a:p>
         </p:txBody>
       </p:sp>
@@ -12504,6 +12635,7 @@
           <a:lstStyle/>
           <a:p>
             <a:pPr algn="ctr"/>
+            <a:endParaRPr/>
           </a:p>
         </p:txBody>
       </p:sp>
@@ -12590,6 +12722,7 @@
           <a:lstStyle/>
           <a:p>
             <a:pPr algn="ctr"/>
+            <a:endParaRPr/>
           </a:p>
         </p:txBody>
       </p:sp>
@@ -12718,6 +12851,7 @@
           <a:lstStyle/>
           <a:p>
             <a:pPr algn="ctr"/>
+            <a:endParaRPr/>
           </a:p>
         </p:txBody>
       </p:sp>
@@ -12804,6 +12938,7 @@
           <a:lstStyle/>
           <a:p>
             <a:pPr algn="ctr"/>
+            <a:endParaRPr/>
           </a:p>
         </p:txBody>
       </p:sp>
@@ -12932,6 +13067,7 @@
           <a:lstStyle/>
           <a:p>
             <a:pPr algn="ctr"/>
+            <a:endParaRPr/>
           </a:p>
         </p:txBody>
       </p:sp>
@@ -12986,7 +13122,7 @@
 </file>
 
 <file path=ppt/slides/slide4.xml><?xml version="1.0" encoding="utf-8"?>
-<p:sld xmlns:a="http://schemas.openxmlformats.org/drawingml/2006/main" xmlns:p="http://schemas.openxmlformats.org/presentationml/2006/main" xmlns:r="http://schemas.openxmlformats.org/officeDocument/2006/relationships">
+<p:sld xmlns:a="http://schemas.openxmlformats.org/drawingml/2006/main" xmlns:r="http://schemas.openxmlformats.org/officeDocument/2006/relationships" xmlns:p="http://schemas.openxmlformats.org/presentationml/2006/main">
   <p:cSld>
     <p:bg>
       <p:bgPr>
@@ -13002,7 +13138,14 @@
         <p:cNvGrpSpPr/>
         <p:nvPr/>
       </p:nvGrpSpPr>
-      <p:grpSpPr/>
+      <p:grpSpPr>
+        <a:xfrm>
+          <a:off x="0" y="0"/>
+          <a:ext cx="0" cy="0"/>
+          <a:chOff x="0" y="0"/>
+          <a:chExt cx="0" cy="0"/>
+        </a:xfrm>
+      </p:grpSpPr>
       <p:sp>
         <p:nvSpPr>
           <p:cNvPr id="2" name="TextBox 1"/>
@@ -13180,7 +13323,7 @@
 </file>
 
 <file path=ppt/slides/slide5.xml><?xml version="1.0" encoding="utf-8"?>
-<p:sld xmlns:a="http://schemas.openxmlformats.org/drawingml/2006/main" xmlns:p="http://schemas.openxmlformats.org/presentationml/2006/main" xmlns:r="http://schemas.openxmlformats.org/officeDocument/2006/relationships">
+<p:sld xmlns:a="http://schemas.openxmlformats.org/drawingml/2006/main" xmlns:r="http://schemas.openxmlformats.org/officeDocument/2006/relationships" xmlns:p="http://schemas.openxmlformats.org/presentationml/2006/main">
   <p:cSld>
     <p:bg>
       <p:bgPr>
@@ -13196,7 +13339,14 @@
         <p:cNvGrpSpPr/>
         <p:nvPr/>
       </p:nvGrpSpPr>
-      <p:grpSpPr/>
+      <p:grpSpPr>
+        <a:xfrm>
+          <a:off x="0" y="0"/>
+          <a:ext cx="0" cy="0"/>
+          <a:chOff x="0" y="0"/>
+          <a:chExt cx="0" cy="0"/>
+        </a:xfrm>
+      </p:grpSpPr>
       <p:sp>
         <p:nvSpPr>
           <p:cNvPr id="2" name="TextBox 1"/>
@@ -13364,6 +13514,7 @@
           <a:lstStyle/>
           <a:p>
             <a:pPr algn="ctr"/>
+            <a:endParaRPr/>
           </a:p>
         </p:txBody>
       </p:sp>
@@ -13450,6 +13601,7 @@
           <a:lstStyle/>
           <a:p>
             <a:pPr algn="ctr"/>
+            <a:endParaRPr/>
           </a:p>
         </p:txBody>
       </p:sp>
@@ -13502,15 +13654,12 @@
                 <a:spcPts val="0"/>
               </a:spcAft>
             </a:pPr>
-            <a:r>
-              <a:rPr sz="1300" b="0">
-                <a:solidFill>
-                  <a:srgbClr val="CADCFC"/>
-                </a:solidFill>
-                <a:latin typeface="Courier New"/>
-              </a:rPr>
-              <a:t/>
-            </a:r>
+            <a:endParaRPr sz="1300" b="0">
+              <a:solidFill>
+                <a:srgbClr val="CADCFC"/>
+              </a:solidFill>
+              <a:latin typeface="Courier New"/>
+            </a:endParaRPr>
           </a:p>
           <a:p>
             <a:pPr>
@@ -13603,7 +13752,7 @@
 </file>
 
 <file path=ppt/slides/slide6.xml><?xml version="1.0" encoding="utf-8"?>
-<p:sld xmlns:a="http://schemas.openxmlformats.org/drawingml/2006/main" xmlns:p="http://schemas.openxmlformats.org/presentationml/2006/main" xmlns:r="http://schemas.openxmlformats.org/officeDocument/2006/relationships">
+<p:sld xmlns:a="http://schemas.openxmlformats.org/drawingml/2006/main" xmlns:r="http://schemas.openxmlformats.org/officeDocument/2006/relationships" xmlns:p="http://schemas.openxmlformats.org/presentationml/2006/main">
   <p:cSld>
     <p:bg>
       <p:bgPr>
@@ -13619,7 +13768,14 @@
         <p:cNvGrpSpPr/>
         <p:nvPr/>
       </p:nvGrpSpPr>
-      <p:grpSpPr/>
+      <p:grpSpPr>
+        <a:xfrm>
+          <a:off x="0" y="0"/>
+          <a:ext cx="0" cy="0"/>
+          <a:chOff x="0" y="0"/>
+          <a:chExt cx="0" cy="0"/>
+        </a:xfrm>
+      </p:grpSpPr>
       <p:sp>
         <p:nvSpPr>
           <p:cNvPr id="2" name="TextBox 1"/>
@@ -13787,6 +13943,7 @@
           <a:lstStyle/>
           <a:p>
             <a:pPr algn="ctr"/>
+            <a:endParaRPr/>
           </a:p>
         </p:txBody>
       </p:sp>
@@ -13873,6 +14030,7 @@
           <a:lstStyle/>
           <a:p>
             <a:pPr algn="ctr"/>
+            <a:endParaRPr/>
           </a:p>
         </p:txBody>
       </p:sp>
@@ -13982,15 +14140,12 @@
                 <a:spcPts val="0"/>
               </a:spcAft>
             </a:pPr>
-            <a:r>
-              <a:rPr sz="1300" b="0">
-                <a:solidFill>
-                  <a:srgbClr val="CADCFC"/>
-                </a:solidFill>
-                <a:latin typeface="Courier New"/>
-              </a:rPr>
-              <a:t/>
-            </a:r>
+            <a:endParaRPr sz="1300" b="0">
+              <a:solidFill>
+                <a:srgbClr val="8895A7"/>
+              </a:solidFill>
+              <a:latin typeface="Courier New"/>
+            </a:endParaRPr>
           </a:p>
           <a:p>
             <a:pPr>
@@ -14041,7 +14196,7 @@
 </file>
 
 <file path=ppt/slides/slide7.xml><?xml version="1.0" encoding="utf-8"?>
-<p:sld xmlns:a="http://schemas.openxmlformats.org/drawingml/2006/main" xmlns:p="http://schemas.openxmlformats.org/presentationml/2006/main" xmlns:r="http://schemas.openxmlformats.org/officeDocument/2006/relationships">
+<p:sld xmlns:a="http://schemas.openxmlformats.org/drawingml/2006/main" xmlns:r="http://schemas.openxmlformats.org/officeDocument/2006/relationships" xmlns:p="http://schemas.openxmlformats.org/presentationml/2006/main">
   <p:cSld>
     <p:bg>
       <p:bgPr>
@@ -14057,7 +14212,14 @@
         <p:cNvGrpSpPr/>
         <p:nvPr/>
       </p:nvGrpSpPr>
-      <p:grpSpPr/>
+      <p:grpSpPr>
+        <a:xfrm>
+          <a:off x="0" y="0"/>
+          <a:ext cx="0" cy="0"/>
+          <a:chOff x="0" y="0"/>
+          <a:chExt cx="0" cy="0"/>
+        </a:xfrm>
+      </p:grpSpPr>
       <p:sp>
         <p:nvSpPr>
           <p:cNvPr id="2" name="TextBox 1"/>
@@ -14235,7 +14397,7 @@
 </file>
 
 <file path=ppt/slides/slide8.xml><?xml version="1.0" encoding="utf-8"?>
-<p:sld xmlns:a="http://schemas.openxmlformats.org/drawingml/2006/main" xmlns:p="http://schemas.openxmlformats.org/presentationml/2006/main" xmlns:r="http://schemas.openxmlformats.org/officeDocument/2006/relationships">
+<p:sld xmlns:a="http://schemas.openxmlformats.org/drawingml/2006/main" xmlns:r="http://schemas.openxmlformats.org/officeDocument/2006/relationships" xmlns:p="http://schemas.openxmlformats.org/presentationml/2006/main">
   <p:cSld>
     <p:bg>
       <p:bgPr>
@@ -14251,7 +14413,14 @@
         <p:cNvGrpSpPr/>
         <p:nvPr/>
       </p:nvGrpSpPr>
-      <p:grpSpPr/>
+      <p:grpSpPr>
+        <a:xfrm>
+          <a:off x="0" y="0"/>
+          <a:ext cx="0" cy="0"/>
+          <a:chOff x="0" y="0"/>
+          <a:chExt cx="0" cy="0"/>
+        </a:xfrm>
+      </p:grpSpPr>
       <p:sp>
         <p:nvSpPr>
           <p:cNvPr id="2" name="TextBox 1"/>
@@ -14419,6 +14588,7 @@
           <a:lstStyle/>
           <a:p>
             <a:pPr algn="ctr"/>
+            <a:endParaRPr/>
           </a:p>
         </p:txBody>
       </p:sp>
@@ -14505,6 +14675,7 @@
           <a:lstStyle/>
           <a:p>
             <a:pPr algn="ctr"/>
+            <a:endParaRPr/>
           </a:p>
         </p:txBody>
       </p:sp>
@@ -14595,15 +14766,12 @@
                 <a:spcPts val="0"/>
               </a:spcAft>
             </a:pPr>
-            <a:r>
-              <a:rPr sz="1300" b="0">
-                <a:solidFill>
-                  <a:srgbClr val="CADCFC"/>
-                </a:solidFill>
-                <a:latin typeface="Courier New"/>
-              </a:rPr>
-              <a:t/>
-            </a:r>
+            <a:endParaRPr sz="1300" b="1">
+              <a:solidFill>
+                <a:srgbClr val="E8A33D"/>
+              </a:solidFill>
+              <a:latin typeface="Courier New"/>
+            </a:endParaRPr>
           </a:p>
           <a:p>
             <a:pPr>
@@ -14696,7 +14864,7 @@
 </file>
 
 <file path=ppt/slides/slide9.xml><?xml version="1.0" encoding="utf-8"?>
-<p:sld xmlns:a="http://schemas.openxmlformats.org/drawingml/2006/main" xmlns:p="http://schemas.openxmlformats.org/presentationml/2006/main" xmlns:r="http://schemas.openxmlformats.org/officeDocument/2006/relationships">
+<p:sld xmlns:a="http://schemas.openxmlformats.org/drawingml/2006/main" xmlns:r="http://schemas.openxmlformats.org/officeDocument/2006/relationships" xmlns:p="http://schemas.openxmlformats.org/presentationml/2006/main">
   <p:cSld>
     <p:bg>
       <p:bgPr>
@@ -14712,7 +14880,14 @@
         <p:cNvGrpSpPr/>
         <p:nvPr/>
       </p:nvGrpSpPr>
-      <p:grpSpPr/>
+      <p:grpSpPr>
+        <a:xfrm>
+          <a:off x="0" y="0"/>
+          <a:ext cx="0" cy="0"/>
+          <a:chOff x="0" y="0"/>
+          <a:chExt cx="0" cy="0"/>
+        </a:xfrm>
+      </p:grpSpPr>
       <p:sp>
         <p:nvSpPr>
           <p:cNvPr id="2" name="TextBox 1"/>
@@ -14880,6 +15055,7 @@
           <a:lstStyle/>
           <a:p>
             <a:pPr algn="ctr"/>
+            <a:endParaRPr/>
           </a:p>
         </p:txBody>
       </p:sp>
@@ -14993,6 +15169,22 @@
                 <a:spcPts val="0"/>
               </a:spcAft>
             </a:pPr>
+            <a:endParaRPr sz="1400" b="0">
+              <a:solidFill>
+                <a:srgbClr val="0E1B2B"/>
+              </a:solidFill>
+              <a:latin typeface="Calibri"/>
+            </a:endParaRPr>
+          </a:p>
+          <a:p>
+            <a:pPr algn="l">
+              <a:spcBef>
+                <a:spcPts val="0"/>
+              </a:spcBef>
+              <a:spcAft>
+                <a:spcPts val="0"/>
+              </a:spcAft>
+            </a:pPr>
             <a:r>
               <a:rPr sz="1400" b="0">
                 <a:solidFill>
@@ -15000,25 +15192,6 @@
                 </a:solidFill>
                 <a:latin typeface="Calibri"/>
               </a:rPr>
-              <a:t/>
-            </a:r>
-          </a:p>
-          <a:p>
-            <a:pPr algn="l">
-              <a:spcBef>
-                <a:spcPts val="0"/>
-              </a:spcBef>
-              <a:spcAft>
-                <a:spcPts val="0"/>
-              </a:spcAft>
-            </a:pPr>
-            <a:r>
-              <a:rPr sz="1400" b="0">
-                <a:solidFill>
-                  <a:srgbClr val="0E1B2B"/>
-                </a:solidFill>
-                <a:latin typeface="Calibri"/>
-              </a:rPr>
               <a:t>Those two arrows point almost the same way -- high cosine similarity.</a:t>
             </a:r>
           </a:p>
@@ -15031,15 +15204,12 @@
                 <a:spcPts val="0"/>
               </a:spcAft>
             </a:pPr>
-            <a:r>
-              <a:rPr sz="1400" b="0">
-                <a:solidFill>
-                  <a:srgbClr val="0E1B2B"/>
-                </a:solidFill>
-                <a:latin typeface="Calibri"/>
-              </a:rPr>
-              <a:t/>
-            </a:r>
+            <a:endParaRPr sz="1400" b="0">
+              <a:solidFill>
+                <a:srgbClr val="0E1B2B"/>
+              </a:solidFill>
+              <a:latin typeface="Calibri"/>
+            </a:endParaRPr>
           </a:p>
           <a:p>
             <a:pPr algn="l">
@@ -15103,6 +15273,7 @@
           <a:lstStyle/>
           <a:p>
             <a:pPr algn="ctr"/>
+            <a:endParaRPr/>
           </a:p>
         </p:txBody>
       </p:sp>
@@ -15235,15 +15406,12 @@
                 <a:spcPts val="0"/>
               </a:spcAft>
             </a:pPr>
-            <a:r>
-              <a:rPr sz="1400" b="0">
-                <a:solidFill>
-                  <a:srgbClr val="FFFFFF"/>
-                </a:solidFill>
-                <a:latin typeface="Calibri"/>
-              </a:rPr>
-              <a:t/>
-            </a:r>
+            <a:endParaRPr sz="1400" b="0">
+              <a:solidFill>
+                <a:srgbClr val="FFFFFF"/>
+              </a:solidFill>
+              <a:latin typeface="Calibri"/>
+            </a:endParaRPr>
           </a:p>
           <a:p>
             <a:pPr algn="l">

</xml_diff>